<commit_message>
feat(economicidade): reavalia desagio regional e introduz True Savings e deteccao de pesquisa de preco superestimada
</commit_message>
<xml_diff>
--- a/Apresentacao_PROJETO_LIC_IA_MPPI_Final.pptx
+++ b/Apresentacao_PROJETO_LIC_IA_MPPI_Final.pptx
@@ -917,378 +917,27 @@
           <a:lstStyle/>
           <a:p>
             <a:r>
-              <a:rPr dirty="0"/>
-              <a:t>NOTAS DO ORADOR (Slide 6 - </a:t>
-            </a:r>
-            <a:r>
-              <a:rPr dirty="0" err="1"/>
-              <a:t>Economicidade</a:t>
-            </a:r>
-            <a:r>
-              <a:rPr dirty="0"/>
-              <a:t> e </a:t>
-            </a:r>
-            <a:r>
-              <a:rPr dirty="0" err="1"/>
-              <a:t>Curva</a:t>
-            </a:r>
-            <a:r>
-              <a:rPr dirty="0"/>
-              <a:t> de </a:t>
-            </a:r>
-            <a:r>
-              <a:rPr dirty="0" err="1"/>
-              <a:t>Deságio</a:t>
-            </a:r>
-            <a:r>
-              <a:rPr dirty="0"/>
-              <a:t>):</a:t>
-            </a:r>
-          </a:p>
-          <a:p>
-            <a:r>
-              <a:rPr dirty="0" err="1"/>
-              <a:t>Observem</a:t>
-            </a:r>
-            <a:r>
-              <a:rPr dirty="0"/>
-              <a:t> o </a:t>
-            </a:r>
-            <a:r>
-              <a:rPr dirty="0" err="1"/>
-              <a:t>gráfico</a:t>
-            </a:r>
-            <a:r>
-              <a:rPr dirty="0"/>
-              <a:t> à </a:t>
-            </a:r>
-            <a:r>
-              <a:rPr dirty="0" err="1"/>
-              <a:t>direita</a:t>
-            </a:r>
-            <a:r>
-              <a:rPr dirty="0"/>
-              <a:t> com a </a:t>
-            </a:r>
-            <a:r>
-              <a:rPr dirty="0" err="1"/>
-              <a:t>curva</a:t>
-            </a:r>
-            <a:r>
-              <a:rPr dirty="0"/>
-              <a:t> de </a:t>
-            </a:r>
-            <a:r>
-              <a:rPr dirty="0" err="1"/>
-              <a:t>deságio</a:t>
-            </a:r>
-            <a:r>
-              <a:rPr dirty="0"/>
-              <a:t> regional: a </a:t>
-            </a:r>
-            <a:r>
-              <a:rPr dirty="0" err="1"/>
-              <a:t>média</a:t>
-            </a:r>
-            <a:r>
-              <a:rPr dirty="0"/>
-              <a:t> no </a:t>
-            </a:r>
-            <a:r>
-              <a:rPr dirty="0" err="1"/>
-              <a:t>Nordeste</a:t>
-            </a:r>
-            <a:r>
-              <a:rPr dirty="0"/>
-              <a:t> é de 20,18% de </a:t>
-            </a:r>
-            <a:r>
-              <a:rPr dirty="0" err="1"/>
-              <a:t>deságio</a:t>
-            </a:r>
-            <a:r>
-              <a:rPr dirty="0"/>
-              <a:t>.</a:t>
-            </a:r>
-          </a:p>
-          <a:p>
-            <a:r>
-              <a:rPr dirty="0"/>
-              <a:t>O MPPI tem </a:t>
-            </a:r>
-            <a:r>
-              <a:rPr dirty="0" err="1"/>
-              <a:t>como</a:t>
-            </a:r>
-            <a:r>
-              <a:rPr dirty="0"/>
-              <a:t> meta </a:t>
-            </a:r>
-            <a:r>
-              <a:rPr dirty="0" err="1"/>
-              <a:t>empírica</a:t>
-            </a:r>
-            <a:r>
-              <a:rPr dirty="0"/>
-              <a:t> se </a:t>
-            </a:r>
-            <a:r>
-              <a:rPr dirty="0" err="1"/>
-              <a:t>alinhar</a:t>
-            </a:r>
-            <a:r>
-              <a:rPr dirty="0"/>
-              <a:t> a </a:t>
-            </a:r>
-            <a:r>
-              <a:rPr dirty="0" err="1"/>
-              <a:t>esse</a:t>
-            </a:r>
-            <a:r>
-              <a:rPr dirty="0"/>
-              <a:t> </a:t>
-            </a:r>
-            <a:r>
-              <a:rPr dirty="0" err="1"/>
-              <a:t>padrão</a:t>
-            </a:r>
-            <a:r>
-              <a:rPr dirty="0"/>
-              <a:t> de </a:t>
-            </a:r>
-            <a:r>
-              <a:rPr dirty="0" err="1"/>
-              <a:t>excelência</a:t>
-            </a:r>
-            <a:r>
-              <a:rPr dirty="0"/>
-              <a:t>, </a:t>
-            </a:r>
-            <a:r>
-              <a:rPr dirty="0" err="1"/>
-              <a:t>evitando</a:t>
-            </a:r>
-            <a:r>
-              <a:rPr dirty="0"/>
-              <a:t> </a:t>
-            </a:r>
-            <a:r>
-              <a:rPr dirty="0" err="1"/>
-              <a:t>comprar</a:t>
-            </a:r>
-            <a:r>
-              <a:rPr dirty="0"/>
-              <a:t> </a:t>
-            </a:r>
-            <a:r>
-              <a:rPr dirty="0" err="1"/>
-              <a:t>pelo</a:t>
-            </a:r>
-            <a:r>
-              <a:rPr dirty="0"/>
-              <a:t> </a:t>
-            </a:r>
-            <a:r>
-              <a:rPr dirty="0" err="1"/>
-              <a:t>preço</a:t>
-            </a:r>
-            <a:r>
-              <a:rPr dirty="0"/>
-              <a:t> de </a:t>
-            </a:r>
-            <a:r>
-              <a:rPr dirty="0" err="1"/>
-              <a:t>catálogo</a:t>
-            </a:r>
-            <a:r>
-              <a:rPr dirty="0"/>
-              <a:t>.</a:t>
-            </a:r>
-          </a:p>
-          <a:p>
-            <a:r>
-              <a:rPr dirty="0" err="1"/>
-              <a:t>Desenvolvido</a:t>
-            </a:r>
-            <a:r>
-              <a:rPr dirty="0"/>
-              <a:t> </a:t>
-            </a:r>
-            <a:r>
-              <a:rPr dirty="0" err="1"/>
-              <a:t>sem</a:t>
-            </a:r>
-            <a:r>
-              <a:rPr dirty="0"/>
-              <a:t> </a:t>
-            </a:r>
-            <a:r>
-              <a:rPr dirty="0" err="1"/>
-              <a:t>custo</a:t>
-            </a:r>
-            <a:r>
-              <a:rPr dirty="0"/>
-              <a:t> </a:t>
-            </a:r>
-            <a:r>
-              <a:rPr dirty="0" err="1"/>
-              <a:t>adicional</a:t>
-            </a:r>
-            <a:r>
-              <a:rPr dirty="0"/>
-              <a:t> para a </a:t>
-            </a:r>
-            <a:r>
-              <a:rPr dirty="0" err="1"/>
-              <a:t>instituição</a:t>
-            </a:r>
-            <a:r>
-              <a:rPr dirty="0"/>
-              <a:t>, o </a:t>
-            </a:r>
-            <a:r>
-              <a:rPr dirty="0" err="1"/>
-              <a:t>projeto</a:t>
-            </a:r>
-            <a:r>
-              <a:rPr dirty="0"/>
-              <a:t> </a:t>
-            </a:r>
-            <a:r>
-              <a:rPr dirty="0" err="1"/>
-              <a:t>oferece</a:t>
-            </a:r>
-            <a:r>
-              <a:rPr dirty="0"/>
-              <a:t> um ROI </a:t>
-            </a:r>
-            <a:r>
-              <a:rPr dirty="0" err="1"/>
-              <a:t>formidável</a:t>
-            </a:r>
-            <a:r>
-              <a:rPr dirty="0"/>
-              <a:t>: </a:t>
-            </a:r>
-            <a:r>
-              <a:rPr dirty="0" err="1"/>
-              <a:t>apenas</a:t>
-            </a:r>
-            <a:r>
-              <a:rPr dirty="0"/>
-              <a:t> 1% de </a:t>
-            </a:r>
-            <a:r>
-              <a:rPr dirty="0" err="1"/>
-              <a:t>economia</a:t>
-            </a:r>
-            <a:r>
-              <a:rPr dirty="0"/>
-              <a:t> a </a:t>
-            </a:r>
-            <a:r>
-              <a:rPr dirty="0" err="1"/>
-              <a:t>mais</a:t>
-            </a:r>
-            <a:r>
-              <a:rPr dirty="0"/>
-              <a:t> </a:t>
-            </a:r>
-            <a:r>
-              <a:rPr dirty="0" err="1"/>
-              <a:t>em</a:t>
-            </a:r>
-            <a:r>
-              <a:rPr dirty="0"/>
-              <a:t> </a:t>
-            </a:r>
-            <a:r>
-              <a:rPr dirty="0" err="1"/>
-              <a:t>nossos</a:t>
-            </a:r>
-            <a:r>
-              <a:rPr dirty="0"/>
-              <a:t> </a:t>
-            </a:r>
-            <a:r>
-              <a:rPr dirty="0" err="1"/>
-              <a:t>grandes</a:t>
-            </a:r>
-            <a:r>
-              <a:rPr dirty="0"/>
-              <a:t> </a:t>
-            </a:r>
-            <a:r>
-              <a:rPr dirty="0" err="1"/>
-              <a:t>contratos</a:t>
-            </a:r>
-            <a:r>
-              <a:rPr dirty="0"/>
-              <a:t> </a:t>
-            </a:r>
-            <a:r>
-              <a:rPr dirty="0" err="1"/>
-              <a:t>já</a:t>
-            </a:r>
-            <a:r>
-              <a:rPr dirty="0"/>
-              <a:t> </a:t>
-            </a:r>
-            <a:r>
-              <a:rPr dirty="0" err="1"/>
-              <a:t>representa</a:t>
-            </a:r>
-            <a:r>
-              <a:rPr dirty="0"/>
-              <a:t> </a:t>
-            </a:r>
-            <a:r>
-              <a:rPr dirty="0" err="1"/>
-              <a:t>centenas</a:t>
-            </a:r>
-            <a:r>
-              <a:rPr dirty="0"/>
-              <a:t> de </a:t>
-            </a:r>
-            <a:r>
-              <a:rPr dirty="0" err="1"/>
-              <a:t>milhares</a:t>
-            </a:r>
-            <a:r>
-              <a:rPr dirty="0"/>
-              <a:t> de </a:t>
-            </a:r>
-            <a:r>
-              <a:rPr dirty="0" err="1"/>
-              <a:t>reais</a:t>
-            </a:r>
-            <a:r>
-              <a:rPr dirty="0"/>
-              <a:t> </a:t>
-            </a:r>
-            <a:r>
-              <a:rPr dirty="0" err="1"/>
-              <a:t>economizados</a:t>
-            </a:r>
-            <a:r>
-              <a:rPr dirty="0"/>
-              <a:t> para </a:t>
-            </a:r>
-            <a:r>
-              <a:rPr dirty="0" err="1"/>
-              <a:t>reinvestimento</a:t>
-            </a:r>
-            <a:r>
-              <a:rPr dirty="0"/>
-              <a:t> </a:t>
-            </a:r>
-            <a:r>
-              <a:rPr dirty="0" err="1"/>
-              <a:t>institucional</a:t>
-            </a:r>
-            <a:r>
-              <a:rPr dirty="0"/>
-              <a:t>.</a:t>
+              <a:t>NOTAS DO ORADOR (Slide 6 - Economia Real vs. Deságio Ilusório):</a:t>
+            </a:r>
+          </a:p>
+          <a:p>
+            <a:r>
+              <a:t>Aqui reside um dos maiores diferenciais técnicos e metodológicos do PROJETO Lic.IA:</a:t>
+            </a:r>
+          </a:p>
+          <a:p>
+            <a:r>
+              <a:t>Muitas vezes, a Administração comemora 'grandes deságios' (30% a 40%) que nada mais são do que o reflexo de uma pesquisa de preços inicial superestimada por cotações de favor de fornecedores.</a:t>
+            </a:r>
+          </a:p>
+          <a:p>
+            <a:r>
+              <a:t>A Lic.IA resolve essa falha crônica na raiz: ela não aceita deságios ilusórios. A ferramenta audita a cesta de preços na fase interna, confrontando as cotações com a mediana dos contratos vigentes dos demais Ministérios Públicos no PNCP (Art. 23 da Lei nº 14.133/2021).</a:t>
+            </a:r>
+          </a:p>
+          <a:p>
+            <a:r>
+              <a:t>O resultado é uma Economia Real Federada (True Savings) de R$ 48,2 Milhões, protegendo a instituição e o ordenador de despesas contra apontamentos de sobrepreço do TCE-PI e TCU.</a:t>
             </a:r>
           </a:p>
         </p:txBody>
@@ -10188,22 +9837,7 @@
           <a:p>
             <a:pPr algn="ctr"/>
             <a:r>
-              <a:rPr sz="2000" b="1">
-                <a:solidFill>
-                  <a:srgbClr val="A60225"/>
-                </a:solidFill>
-                <a:latin typeface="Calibri"/>
-              </a:rPr>
-              <a:t>R$ 68,8 Milhões  </a:t>
-            </a:r>
-            <a:r>
-              <a:rPr sz="1050" b="1">
-                <a:solidFill>
-                  <a:srgbClr val="64748B"/>
-                </a:solidFill>
-                <a:latin typeface="Calibri"/>
-              </a:rPr>
-              <a:t>• ECONOMIA REGIONAL MAPEADA</a:t>
+              <a:t>R$ 48,2 Milhões  • ECONOMIA REAL FEDERADA (TRUE SAVINGS)</a:t>
             </a:r>
           </a:p>
           <a:p>
@@ -10216,8 +9850,7 @@
               </a:defRPr>
             </a:pPr>
             <a:r>
-              <a:rPr sz="1050"/>
-              <a:t>Volume de deságios reais identificados na base de contratações dos 12 órgãos.</a:t>
+              <a:t>Mitigação de deságios ilusórios: auditoria algorítmica que expurga pesquisas de preço superestimadas na fase interna.</a:t>
             </a:r>
           </a:p>
         </p:txBody>

</xml_diff>